<commit_message>
Add exterior and interior photos to recruitment deck
Co-Authored-By: Claude Opus 5.5 <noreply@anthropic.com>
Claude-Session: https://claude.ai/code/session_01CK7zuGnG2F5huUMaTkemix
</commit_message>
<xml_diff>
--- a/docs/recruiting/uchi-careplan-center_recruit-deck.pptx
+++ b/docs/recruiting/uchi-careplan-center_recruit-deck.pptx
@@ -121,19 +121,19 @@
   <p:extLst>
     <p:ext uri="{521415D9-36F7-43E2-AB2F-B90AF26B5E84}">
       <p14:sectionLst xmlns:p14="http://schemas.microsoft.com/office/powerpoint/2010/main">
-        <p14:section name="はじめに" id="{ba2e07b1-6232-37fd-9d1c-63b003478c5d}">
+        <p14:section name="はじめに" id="{f72cb743-1473-2a64-687d-d35872e82cf8}">
           <p14:sldIdLst>
             <p14:sldId id="256"/>
             <p14:sldId id="257"/>
           </p14:sldIdLst>
         </p14:section>
-        <p14:section name="理念と支援" id="{55f2f4ac-6f3d-517d-5e23-fa8565f0cf1f}">
+        <p14:section name="理念と支援" id="{3efc34d8-f687-18b2-71a8-a96f798124dc}">
           <p14:sldIdLst>
             <p14:sldId id="258"/>
             <p14:sldId id="259"/>
           </p14:sldIdLst>
         </p14:section>
-        <p14:section name="仕事と環境" id="{f814f8cb-be5c-8739-7930-63b781db80af}">
+        <p14:section name="仕事と環境" id="{d1a5fd41-a513-1ff3-e184-d96470471580}">
           <p14:sldIdLst>
             <p14:sldId id="260"/>
             <p14:sldId id="261"/>
@@ -141,19 +141,19 @@
             <p14:sldId id="263"/>
           </p14:sldIdLst>
         </p14:section>
-        <p14:section name="一緒に働く" id="{393d8a44-9014-ab0f-64ac-ccbd808dcebf}">
+        <p14:section name="一緒に働く" id="{2bb90be9-943a-2fd6-2ddc-b11abd6549c7}">
           <p14:sldIdLst>
             <p14:sldId id="264"/>
             <p14:sldId id="265"/>
           </p14:sldIdLst>
         </p14:section>
-        <p14:section name="募集と見学" id="{c2722c0f-ca72-286e-6908-785b0b989664}">
+        <p14:section name="募集と見学" id="{71332293-4961-cc53-f218-6401ed6ad95e}">
           <p14:sldIdLst>
             <p14:sldId id="266"/>
             <p14:sldId id="267"/>
           </p14:sldIdLst>
         </p14:section>
-        <p14:section name="作成者用（公開前に削除）" id="{d68e707a-1a2a-be70-96de-990f7e3a1ec3}">
+        <p14:section name="作成者用（公開前に削除）" id="{4c1be000-54ae-4392-602d-5f09c525febd}">
           <p14:sldIdLst>
             <p14:sldId id="268"/>
             <p14:sldId id="269"/>
@@ -7222,7 +7222,7 @@
                   <a:schemeClr val="tx1"/>
                 </a:solidFill>
               </a:rPr>
-              <a:t>事業所外観・事務所・端末・社有車の写真撮影（差し替え枠3か所）</a:t>
+              <a:t>外観・室内写真が事業所のものか、掲載可否／端末・社有車の写真撮影</a:t>
             </a:r>
             <a:endParaRPr lang="en-US" sz="1400" dirty="0"/>
           </a:p>
@@ -7775,80 +7775,65 @@
           </a:p>
         </p:txBody>
       </p:sp>
-      <p:sp>
-        <p:nvSpPr>
-          <p:cNvPr id="15" name="photo frame office"/>
-          <p:cNvSpPr/>
-          <p:nvPr/>
-        </p:nvSpPr>
+      <p:pic>
+        <p:nvPicPr>
+          <p:cNvPr id="15" name="exterior photo" descr="/tmp/claude-0/-home-user-UCHICARE/0e7d8274-02c5-574f-9991-dce834059096/scratchpad/exterior.jpg">    </p:cNvPr>
+          <p:cNvPicPr>
+            <a:picLocks noChangeAspect="1"/>
+          </p:cNvPicPr>
+          <p:nvPr/>
+        </p:nvPicPr>
+        <p:blipFill>
+          <a:blip r:embed="rId4"/>
+          <a:srcRect l="0" r="0" t="0" b="0"/>
+          <a:stretch/>
+        </p:blipFill>
         <p:spPr>
           <a:xfrm>
             <a:off x="7178040" y="1371600"/>
-            <a:ext cx="4480560" cy="3200400"/>
-          </a:xfrm>
-          <a:prstGeom prst="roundRect">
-            <a:avLst>
-              <a:gd name="adj" fmla="val 2857"/>
-            </a:avLst>
-          </a:prstGeom>
-          <a:solidFill>
-            <a:schemeClr val="bg2"/>
-          </a:solidFill>
-          <a:ln w="19050">
-            <a:solidFill>
-              <a:schemeClr val="accent2"/>
-            </a:solidFill>
-            <a:prstDash val="dash"/>
-          </a:ln>
-        </p:spPr>
-      </p:sp>
-      <p:sp>
-        <p:nvSpPr>
-          <p:cNvPr id="16" name="Text 11"/>
+            <a:ext cx="4480560" cy="3017520"/>
+          </a:xfrm>
+          <a:prstGeom prst="rect">
+            <a:avLst/>
+          </a:prstGeom>
+        </p:spPr>
+      </p:pic>
+      <p:sp>
+        <p:nvSpPr>
+          <p:cNvPr id="16" name="Text 10"/>
           <p:cNvSpPr txBox="1"/>
           <p:nvPr/>
         </p:nvSpPr>
         <p:spPr>
           <a:xfrm>
-            <a:off x="7178040" y="1371600"/>
-            <a:ext cx="4480560" cy="3200400"/>
-          </a:xfrm>
-          <a:prstGeom prst="rect">
-            <a:avLst/>
-          </a:prstGeom>
-          <a:noFill/>
-          <a:ln/>
-        </p:spPr>
-        <p:txBody>
-          <a:bodyPr wrap="square" lIns="1905" tIns="1905" rIns="1905" bIns="1905" rtlCol="0" anchor="ctr"/>
-          <a:lstStyle/>
-          <a:p>
-            <a:pPr algn="ctr" indent="0" marL="0">
-              <a:buNone/>
-            </a:pPr>
-            <a:r>
-              <a:rPr lang="en-US" sz="1300" dirty="0">
+            <a:off x="7178040" y="4443984"/>
+            <a:ext cx="4480560" cy="256032"/>
+          </a:xfrm>
+          <a:prstGeom prst="rect">
+            <a:avLst/>
+          </a:prstGeom>
+          <a:noFill/>
+          <a:ln/>
+        </p:spPr>
+        <p:txBody>
+          <a:bodyPr wrap="square" lIns="0" tIns="0" rIns="0" bIns="0" rtlCol="0" anchor="t"/>
+          <a:lstStyle/>
+          <a:p>
+            <a:pPr algn="r" indent="0" marL="0">
+              <a:lnSpc>
+                <a:spcPct val="115000"/>
+              </a:lnSpc>
+              <a:buNone/>
+            </a:pPr>
+            <a:r>
+              <a:rPr lang="en-US" sz="1100" dirty="0">
                 <a:solidFill>
                   <a:schemeClr val="accent5"/>
                 </a:solidFill>
               </a:rPr>
-              <a:t>写真差し替え枠</a:t>
-            </a:r>
-            <a:endParaRPr lang="en-US" sz="1300" dirty="0"/>
-          </a:p>
-          <a:p>
-            <a:pPr algn="ctr" indent="0" marL="0">
-              <a:buNone/>
-            </a:pPr>
-            <a:r>
-              <a:rPr lang="en-US" sz="1300" dirty="0">
-                <a:solidFill>
-                  <a:schemeClr val="accent5"/>
-                </a:solidFill>
-              </a:rPr>
-              <a:t>事業所の外観・事務所の様子</a:t>
-            </a:r>
-            <a:endParaRPr lang="en-US" sz="1300" dirty="0"/>
+              <a:t>事業所の外観</a:t>
+            </a:r>
+            <a:endParaRPr lang="en-US" sz="1100" dirty="0"/>
           </a:p>
         </p:txBody>
       </p:sp>
@@ -7876,7 +7861,7 @@
       </p:sp>
       <p:sp>
         <p:nvSpPr>
-          <p:cNvPr id="18" name="Text 13"/>
+          <p:cNvPr id="18" name="Text 12"/>
           <p:cNvSpPr txBox="1"/>
           <p:nvPr/>
         </p:nvSpPr>
@@ -12821,20 +12806,82 @@
           </a:p>
         </p:txBody>
       </p:sp>
-      <p:sp>
-        <p:nvSpPr>
-          <p:cNvPr id="18" name="photo frame desk"/>
+      <p:pic>
+        <p:nvPicPr>
+          <p:cNvPr id="18" name="interior photo" descr="/tmp/claude-0/-home-user-UCHICARE/0e7d8274-02c5-574f-9991-dce834059096/scratchpad/interior.jpg">    </p:cNvPr>
+          <p:cNvPicPr>
+            <a:picLocks noChangeAspect="1"/>
+          </p:cNvPicPr>
+          <p:nvPr/>
+        </p:nvPicPr>
+        <p:blipFill>
+          <a:blip r:embed="rId4"/>
+          <a:srcRect l="0" r="0" t="0" b="0"/>
+          <a:stretch/>
+        </p:blipFill>
+        <p:spPr>
+          <a:xfrm>
+            <a:off x="6949440" y="1371600"/>
+            <a:ext cx="4709160" cy="3063240"/>
+          </a:xfrm>
+          <a:prstGeom prst="rect">
+            <a:avLst/>
+          </a:prstGeom>
+        </p:spPr>
+      </p:pic>
+      <p:sp>
+        <p:nvSpPr>
+          <p:cNvPr id="19" name="Text 13"/>
+          <p:cNvSpPr txBox="1"/>
+          <p:nvPr/>
+        </p:nvSpPr>
+        <p:spPr>
+          <a:xfrm>
+            <a:off x="6949440" y="4480560"/>
+            <a:ext cx="4709160" cy="256032"/>
+          </a:xfrm>
+          <a:prstGeom prst="rect">
+            <a:avLst/>
+          </a:prstGeom>
+          <a:noFill/>
+          <a:ln/>
+        </p:spPr>
+        <p:txBody>
+          <a:bodyPr wrap="square" lIns="0" tIns="0" rIns="0" bIns="0" rtlCol="0" anchor="t"/>
+          <a:lstStyle/>
+          <a:p>
+            <a:pPr algn="r" indent="0" marL="0">
+              <a:lnSpc>
+                <a:spcPct val="115000"/>
+              </a:lnSpc>
+              <a:buNone/>
+            </a:pPr>
+            <a:r>
+              <a:rPr lang="en-US" sz="1100" dirty="0">
+                <a:solidFill>
+                  <a:schemeClr val="accent5"/>
+                </a:solidFill>
+              </a:rPr>
+              <a:t>事業所の室内</a:t>
+            </a:r>
+            <a:endParaRPr lang="en-US" sz="1100" dirty="0"/>
+          </a:p>
+        </p:txBody>
+      </p:sp>
+      <p:sp>
+        <p:nvSpPr>
+          <p:cNvPr id="20" name="photo frame car"/>
           <p:cNvSpPr/>
           <p:nvPr/>
         </p:nvSpPr>
         <p:spPr>
           <a:xfrm>
-            <a:off x="6949440" y="1371600"/>
-            <a:ext cx="4709160" cy="2240280"/>
+            <a:off x="6949440" y="4846320"/>
+            <a:ext cx="4709160" cy="1234440"/>
           </a:xfrm>
           <a:prstGeom prst="roundRect">
             <a:avLst>
-              <a:gd name="adj" fmla="val 4082"/>
+              <a:gd name="adj" fmla="val 7407"/>
             </a:avLst>
           </a:prstGeom>
           <a:solidFill>
@@ -12850,91 +12897,14 @@
       </p:sp>
       <p:sp>
         <p:nvSpPr>
-          <p:cNvPr id="19" name="Text 14"/>
+          <p:cNvPr id="21" name="Text 15"/>
           <p:cNvSpPr txBox="1"/>
           <p:nvPr/>
         </p:nvSpPr>
         <p:spPr>
           <a:xfrm>
-            <a:off x="6949440" y="1371600"/>
-            <a:ext cx="4709160" cy="2240280"/>
-          </a:xfrm>
-          <a:prstGeom prst="rect">
-            <a:avLst/>
-          </a:prstGeom>
-          <a:noFill/>
-          <a:ln/>
-        </p:spPr>
-        <p:txBody>
-          <a:bodyPr wrap="square" lIns="1905" tIns="1905" rIns="1905" bIns="1905" rtlCol="0" anchor="ctr"/>
-          <a:lstStyle/>
-          <a:p>
-            <a:pPr algn="ctr" indent="0" marL="0">
-              <a:buNone/>
-            </a:pPr>
-            <a:r>
-              <a:rPr lang="en-US" sz="1300" dirty="0">
-                <a:solidFill>
-                  <a:schemeClr val="accent5"/>
-                </a:solidFill>
-              </a:rPr>
-              <a:t>写真差し替え枠</a:t>
-            </a:r>
-            <a:endParaRPr lang="en-US" sz="1300" dirty="0"/>
-          </a:p>
-          <a:p>
-            <a:pPr algn="ctr" indent="0" marL="0">
-              <a:buNone/>
-            </a:pPr>
-            <a:r>
-              <a:rPr lang="en-US" sz="1300" dirty="0">
-                <a:solidFill>
-                  <a:schemeClr val="accent5"/>
-                </a:solidFill>
-              </a:rPr>
-              <a:t>事務所・デスクまわり</a:t>
-            </a:r>
-            <a:endParaRPr lang="en-US" sz="1300" dirty="0"/>
-          </a:p>
-        </p:txBody>
-      </p:sp>
-      <p:sp>
-        <p:nvSpPr>
-          <p:cNvPr id="20" name="photo frame car"/>
-          <p:cNvSpPr/>
-          <p:nvPr/>
-        </p:nvSpPr>
-        <p:spPr>
-          <a:xfrm>
-            <a:off x="6949440" y="3794760"/>
-            <a:ext cx="4709160" cy="2240280"/>
-          </a:xfrm>
-          <a:prstGeom prst="roundRect">
-            <a:avLst>
-              <a:gd name="adj" fmla="val 4082"/>
-            </a:avLst>
-          </a:prstGeom>
-          <a:solidFill>
-            <a:schemeClr val="bg2"/>
-          </a:solidFill>
-          <a:ln w="19050">
-            <a:solidFill>
-              <a:schemeClr val="accent2"/>
-            </a:solidFill>
-            <a:prstDash val="dash"/>
-          </a:ln>
-        </p:spPr>
-      </p:sp>
-      <p:sp>
-        <p:nvSpPr>
-          <p:cNvPr id="21" name="Text 16"/>
-          <p:cNvSpPr txBox="1"/>
-          <p:nvPr/>
-        </p:nvSpPr>
-        <p:spPr>
-          <a:xfrm>
-            <a:off x="6949440" y="3794760"/>
-            <a:ext cx="4709160" cy="2240280"/>
+            <a:off x="6949440" y="4846320"/>
+            <a:ext cx="4709160" cy="1234440"/>
           </a:xfrm>
           <a:prstGeom prst="rect">
             <a:avLst/>

</xml_diff>